<commit_message>
Add #CONFIG tag, debug_skip_slideshow option; fix app.py reading stale config for tick scheduling/watcher
</commit_message>
<xml_diff>
--- a/luah.pptx
+++ b/luah.pptx
@@ -9,6 +9,7 @@
     <p:sldId id="257" r:id="rId3"/>
     <p:sldId id="258" r:id="rId4"/>
     <p:sldId id="259" r:id="rId5"/>
+    <p:sldId id="260" r:id="rId6"/>
   </p:sldIdLst>
   <p:sldSz cx="12192000" cy="6858000"/>
   <p:notesSz cx="7772400" cy="10058400"/>
@@ -11662,7 +11663,7 @@
               </a:spcAft>
             </a:pPr>
             <a:r>
-              <a:rPr lang="he-IL" sz="3200" u="none" strike="noStrike" dirty="0">
+              <a:rPr lang="he-IL" sz="3200" b="1" u="none" strike="noStrike">
                 <a:effectLst/>
                 <a:uFillTx/>
                 <a:latin typeface="Calibri"/>
@@ -11670,7 +11671,7 @@
               <a:t>#</a:t>
             </a:r>
             <a:r>
-              <a:rPr lang="en-US" sz="3200" u="none" strike="noStrike" dirty="0">
+              <a:rPr lang="en-US" sz="3200" b="1" u="none" strike="noStrike">
                 <a:effectLst/>
                 <a:uFillTx/>
                 <a:latin typeface="Calibri"/>
@@ -11678,7 +11679,7 @@
               <a:t>CMD</a:t>
             </a:r>
             <a:r>
-              <a:rPr lang="he-IL" sz="3200" u="none" strike="noStrike" dirty="0">
+              <a:rPr lang="he-IL" sz="3200" b="1" u="none" strike="noStrike">
                 <a:effectLst/>
                 <a:uFillTx/>
                 <a:latin typeface="Calibri"/>
@@ -11686,22 +11687,30 @@
               <a:t>:&lt;</a:t>
             </a:r>
             <a:r>
-              <a:rPr lang="en-US" sz="3200" u="none" strike="noStrike" dirty="0" err="1">
-                <a:effectLst/>
-                <a:uFillTx/>
-                <a:latin typeface="Calibri"/>
-              </a:rPr>
-              <a:t>chol_desc</a:t>
-            </a:r>
-            <a:r>
-              <a:rPr lang="he-IL" sz="3200" u="none" strike="noStrike" dirty="0">
+              <a:rPr lang="en-US" sz="3200" b="1" u="none" strike="noStrike">
+                <a:effectLst/>
+                <a:uFillTx/>
+                <a:latin typeface="Calibri"/>
+              </a:rPr>
+              <a:t>chol</a:t>
+            </a:r>
+            <a:r>
+              <a:rPr lang="en-US" sz="3200" b="1" u="none" strike="noStrike" dirty="0" err="1">
+                <a:effectLst/>
+                <a:uFillTx/>
+                <a:latin typeface="Calibri"/>
+              </a:rPr>
+              <a:t>_desc</a:t>
+            </a:r>
+            <a:r>
+              <a:rPr lang="he-IL" sz="3200" b="1" u="none" strike="noStrike">
                 <a:effectLst/>
                 <a:uFillTx/>
                 <a:latin typeface="Calibri"/>
               </a:rPr>
               <a:t>&gt;</a:t>
             </a:r>
-            <a:endParaRPr lang="en-US" sz="3200" u="none" strike="noStrike" dirty="0">
+            <a:endParaRPr lang="en-US" sz="3200" b="1" u="none" strike="noStrike" dirty="0">
               <a:effectLst/>
               <a:uFillTx/>
               <a:latin typeface="Arial"/>
@@ -11758,7 +11767,7 @@
               </a:spcAft>
             </a:pPr>
             <a:r>
-              <a:rPr lang="he-IL" sz="3200" u="none" strike="noStrike" dirty="0">
+              <a:rPr lang="he-IL" sz="3200" b="1" u="none" strike="noStrike">
                 <a:effectLst/>
                 <a:uFillTx/>
                 <a:latin typeface="Calibri"/>
@@ -11766,7 +11775,7 @@
               <a:t>#</a:t>
             </a:r>
             <a:r>
-              <a:rPr lang="en-US" sz="3200" u="none" strike="noStrike" dirty="0">
+              <a:rPr lang="en-US" sz="3200" b="1" u="none" strike="noStrike">
                 <a:effectLst/>
                 <a:uFillTx/>
                 <a:latin typeface="Calibri"/>
@@ -11774,7 +11783,7 @@
               <a:t>CMD</a:t>
             </a:r>
             <a:r>
-              <a:rPr lang="he-IL" sz="3200" u="none" strike="noStrike" dirty="0">
+              <a:rPr lang="he-IL" sz="3200" b="1" u="none" strike="noStrike">
                 <a:effectLst/>
                 <a:uFillTx/>
                 <a:latin typeface="Calibri"/>
@@ -11782,22 +11791,30 @@
               <a:t>:&lt;</a:t>
             </a:r>
             <a:r>
-              <a:rPr lang="en-US" sz="3200" u="none" strike="noStrike" dirty="0" err="1">
-                <a:effectLst/>
-                <a:uFillTx/>
-                <a:latin typeface="Calibri"/>
-              </a:rPr>
-              <a:t>chol_times</a:t>
-            </a:r>
-            <a:r>
-              <a:rPr lang="he-IL" sz="3200" u="none" strike="noStrike" dirty="0">
+              <a:rPr lang="en-US" sz="3200" b="1" u="none" strike="noStrike">
+                <a:effectLst/>
+                <a:uFillTx/>
+                <a:latin typeface="Calibri"/>
+              </a:rPr>
+              <a:t>chol</a:t>
+            </a:r>
+            <a:r>
+              <a:rPr lang="en-US" sz="3200" b="1" u="none" strike="noStrike" dirty="0" err="1">
+                <a:effectLst/>
+                <a:uFillTx/>
+                <a:latin typeface="Calibri"/>
+              </a:rPr>
+              <a:t>_times</a:t>
+            </a:r>
+            <a:r>
+              <a:rPr lang="he-IL" sz="3200" b="1" u="none" strike="noStrike">
                 <a:effectLst/>
                 <a:uFillTx/>
                 <a:latin typeface="Calibri"/>
               </a:rPr>
               <a:t>&gt;</a:t>
             </a:r>
-            <a:endParaRPr lang="en-US" sz="3200" u="none" strike="noStrike" dirty="0">
+            <a:endParaRPr lang="en-US" sz="3200" b="1" u="none" strike="noStrike" dirty="0">
               <a:effectLst/>
               <a:uFillTx/>
               <a:latin typeface="Arial"/>
@@ -12504,6 +12521,127 @@
     <p:extLst>
       <p:ext uri="{BB962C8B-B14F-4D97-AF65-F5344CB8AC3E}">
         <p14:creationId xmlns:p14="http://schemas.microsoft.com/office/powerpoint/2010/main" val="2515977163"/>
+      </p:ext>
+    </p:extLst>
+  </p:cSld>
+  <p:clrMapOvr>
+    <a:masterClrMapping/>
+  </p:clrMapOvr>
+</p:sld>
+</file>
+
+<file path=ppt/slides/slide5.xml><?xml version="1.0" encoding="utf-8"?>
+<p:sld xmlns:a="http://schemas.openxmlformats.org/drawingml/2006/main" xmlns:r="http://schemas.openxmlformats.org/officeDocument/2006/relationships" xmlns:p="http://schemas.openxmlformats.org/presentationml/2006/main">
+  <p:cSld>
+    <p:spTree>
+      <p:nvGrpSpPr>
+        <p:cNvPr id="1" name=""/>
+        <p:cNvGrpSpPr/>
+        <p:nvPr/>
+      </p:nvGrpSpPr>
+      <p:grpSpPr>
+        <a:xfrm>
+          <a:off x="0" y="0"/>
+          <a:ext cx="0" cy="0"/>
+          <a:chOff x="0" y="0"/>
+          <a:chExt cx="0" cy="0"/>
+        </a:xfrm>
+      </p:grpSpPr>
+      <p:sp>
+        <p:nvSpPr>
+          <p:cNvPr id="4" name="TextBox 3">
+            <a:extLst>
+              <a:ext uri="{FF2B5EF4-FFF2-40B4-BE49-F238E27FC236}">
+                <a16:creationId xmlns:a16="http://schemas.microsoft.com/office/drawing/2014/main" id="{10BDF163-A326-A48D-78C5-8A59F580915C}"/>
+              </a:ext>
+            </a:extLst>
+          </p:cNvPr>
+          <p:cNvSpPr txBox="1"/>
+          <p:nvPr/>
+        </p:nvSpPr>
+        <p:spPr>
+          <a:xfrm>
+            <a:off x="179294" y="98612"/>
+            <a:ext cx="11707906" cy="1754326"/>
+          </a:xfrm>
+          <a:prstGeom prst="rect">
+            <a:avLst/>
+          </a:prstGeom>
+          <a:noFill/>
+        </p:spPr>
+        <p:txBody>
+          <a:bodyPr wrap="square" rtlCol="0">
+            <a:spAutoFit/>
+          </a:bodyPr>
+          <a:lstStyle/>
+          <a:p>
+            <a:r>
+              <a:rPr lang="en-US" dirty="0"/>
+              <a:t>#CONFIG:{</a:t>
+            </a:r>
+          </a:p>
+          <a:p>
+            <a:r>
+              <a:rPr lang="en-US" dirty="0"/>
+              <a:t>"clock_tick_seconds": 1.0,</a:t>
+            </a:r>
+          </a:p>
+          <a:p>
+            <a:r>
+              <a:rPr lang="en-US" dirty="0"/>
+              <a:t>"</a:t>
+            </a:r>
+            <a:r>
+              <a:rPr lang="en-US" dirty="0" err="1"/>
+              <a:t>debug_repaint_nudge_shape</a:t>
+            </a:r>
+            <a:r>
+              <a:rPr lang="en-US" dirty="0"/>
+              <a:t>": true,</a:t>
+            </a:r>
+          </a:p>
+          <a:p>
+            <a:r>
+              <a:rPr lang="en-US" dirty="0"/>
+              <a:t>"</a:t>
+            </a:r>
+            <a:r>
+              <a:rPr lang="en-US" dirty="0" err="1"/>
+              <a:t>clock_style</a:t>
+            </a:r>
+            <a:r>
+              <a:rPr lang="en-US" dirty="0"/>
+              <a:t>":{</a:t>
+            </a:r>
+            <a:r>
+              <a:rPr lang="" dirty="0"/>
+              <a:t>"hour_color": 255</a:t>
+            </a:r>
+            <a:r>
+              <a:rPr lang="en-US" dirty="0"/>
+              <a:t>},</a:t>
+            </a:r>
+          </a:p>
+          <a:p>
+            <a:r>
+              <a:rPr lang="" dirty="0"/>
+              <a:t>"debug_skip_slideshow": false</a:t>
+            </a:r>
+            <a:endParaRPr lang="en-US" dirty="0"/>
+          </a:p>
+          <a:p>
+            <a:r>
+              <a:rPr lang="en-US" dirty="0"/>
+              <a:t>}</a:t>
+            </a:r>
+            <a:endParaRPr lang="LID4096" dirty="0"/>
+          </a:p>
+        </p:txBody>
+      </p:sp>
+    </p:spTree>
+    <p:extLst>
+      <p:ext uri="{BB962C8B-B14F-4D97-AF65-F5344CB8AC3E}">
+        <p14:creationId xmlns:p14="http://schemas.microsoft.com/office/powerpoint/2010/main" val="3506289245"/>
       </p:ext>
     </p:extLst>
   </p:cSld>

</xml_diff>

<commit_message>
presentation: fix tagged text shapes not visibly repainting in live slideshow
Adds a position-based 'nudge' (move shape by 1/100mm and back) to force LibreOffice's live slideshow to repaint a tagged text shape after its content changes - fixes #DICLOCK appearing frozen on slides with no analog clock (which previously got an incidental repaint for free from the clock hands' own per-second writes).

- New debug_repaint_nudge_text_shapes config flag (enabled in config.json)
- New debug_log_content_refresh diagnostic flag (disabled by default) used to confirm root cause
- Aligned debug_repaint_nudge_shape (clock hands) to the same position-based nudge mechanism, replacing an earlier Visible-toggle approach that was found to risk a text shape vanishing from the live slideshow

Includes updated config.json/luah.pptx and new tests (173/173 passing).
</commit_message>
<xml_diff>
--- a/luah.pptx
+++ b/luah.pptx
@@ -17,7 +17,7 @@
   <p:notesSz cx="7772400" cy="10058400"/>
   <p:defaultTextStyle>
     <a:defPPr>
-      <a:defRPr lang="LID4096"/>
+      <a:defRPr lang="x-none"/>
     </a:defPPr>
     <a:lvl1pPr marL="0" algn="l" defTabSz="914400" rtl="0" eaLnBrk="1" latinLnBrk="0" hangingPunct="1">
       <a:defRPr sz="1800" kern="1200">
@@ -118,6 +118,14 @@
 </p:presentation>
 </file>
 
+<file path=ppt/revisionInfo.xml><?xml version="1.0" encoding="utf-8"?>
+<p1510:revInfo xmlns:a="http://schemas.openxmlformats.org/drawingml/2006/main" xmlns:r="http://schemas.openxmlformats.org/officeDocument/2006/relationships" xmlns:p1510="http://schemas.microsoft.com/office/powerpoint/2015/10/main">
+  <p1510:revLst>
+    <p1510:client id="{4EED8FCA-2AB1-1DF8-BA20-BED3CD38F1A2}" v="7" dt="2026-10-08T14:52:30.562"/>
+  </p1510:revLst>
+</p1510:revInfo>
+</file>
+
 <file path=ppt/notesMasters/notesMaster1.xml><?xml version="1.0" encoding="utf-8"?>
 <p:notesMaster xmlns:a="http://schemas.openxmlformats.org/drawingml/2006/main" xmlns:r="http://schemas.openxmlformats.org/officeDocument/2006/relationships" xmlns:p="http://schemas.openxmlformats.org/presentationml/2006/main">
   <p:cSld>
@@ -167,7 +175,7 @@
             </a:lvl1pPr>
           </a:lstStyle>
           <a:p>
-            <a:endParaRPr lang="LID4096"/>
+            <a:endParaRPr lang="x-none"/>
           </a:p>
         </p:txBody>
       </p:sp>
@@ -199,10 +207,10 @@
           </a:lstStyle>
           <a:p>
             <a:fld id="{FD5B471E-2D90-49BC-A0B2-2FC9EAC1BE17}" type="datetimeFigureOut">
-              <a:rPr lang="LID4096" smtClean="0"/>
+              <a:rPr lang="x-none" smtClean="0"/>
               <a:t>10/08/2026</a:t>
             </a:fld>
-            <a:endParaRPr lang="LID4096"/>
+            <a:endParaRPr lang="x-none"/>
           </a:p>
         </p:txBody>
       </p:sp>
@@ -235,7 +243,7 @@
           <a:bodyPr vert="horz" lIns="91440" tIns="45720" rIns="91440" bIns="45720" rtlCol="0" anchor="ctr"/>
           <a:lstStyle/>
           <a:p>
-            <a:endParaRPr lang="LID4096"/>
+            <a:endParaRPr lang="x-none"/>
           </a:p>
         </p:txBody>
       </p:sp>
@@ -295,7 +303,7 @@
               <a:rPr lang="en-US"/>
               <a:t>Fifth level</a:t>
             </a:r>
-            <a:endParaRPr lang="LID4096"/>
+            <a:endParaRPr lang="x-none"/>
           </a:p>
         </p:txBody>
       </p:sp>
@@ -326,7 +334,7 @@
             </a:lvl1pPr>
           </a:lstStyle>
           <a:p>
-            <a:endParaRPr lang="LID4096"/>
+            <a:endParaRPr lang="x-none"/>
           </a:p>
         </p:txBody>
       </p:sp>
@@ -358,10 +366,10 @@
           </a:lstStyle>
           <a:p>
             <a:fld id="{B161048A-9FF3-42A8-9F95-F29AC97CB98C}" type="slidenum">
-              <a:rPr lang="LID4096" smtClean="0"/>
+              <a:rPr lang="x-none" smtClean="0"/>
               <a:t>‹#›</a:t>
             </a:fld>
-            <a:endParaRPr lang="LID4096"/>
+            <a:endParaRPr lang="x-none"/>
           </a:p>
         </p:txBody>
       </p:sp>
@@ -1131,7 +1139,7 @@
               <a:tabLst>
                 <a:tab pos="0" algn="l"/>
               </a:tabLst>
-              <a:defRPr lang="en-IL" sz="1200" b="0" u="none" strike="noStrike">
+              <a:defRPr lang="x-none" sz="1200" b="0" u="none" strike="noStrike">
                 <a:solidFill>
                   <a:schemeClr val="dk1">
                     <a:tint val="75000"/>
@@ -1154,7 +1162,7 @@
               </a:tabLst>
             </a:pPr>
             <a:r>
-              <a:rPr lang="en-IL" sz="1200" b="0" u="none" strike="noStrike">
+              <a:rPr lang="x-none" sz="1200" b="0" u="none" strike="noStrike">
                 <a:solidFill>
                   <a:schemeClr val="dk1">
                     <a:tint val="75000"/>
@@ -1283,7 +1291,7 @@
               <a:tabLst>
                 <a:tab pos="0" algn="l"/>
               </a:tabLst>
-              <a:defRPr lang="en-IL" sz="1200" b="0" u="none" strike="noStrike">
+              <a:defRPr lang="x-none" sz="1200" b="0" u="none" strike="noStrike">
                 <a:solidFill>
                   <a:schemeClr val="dk1">
                     <a:tint val="75000"/>
@@ -1306,7 +1314,7 @@
               </a:tabLst>
             </a:pPr>
             <a:fld id="{5299AE77-7776-4BD1-AB5A-EEC0F4189CFB}" type="slidenum">
-              <a:rPr lang="en-IL" sz="1200" b="0" u="none" strike="noStrike">
+              <a:rPr lang="x-none" sz="1200" b="0" u="none" strike="noStrike">
                 <a:solidFill>
                   <a:schemeClr val="dk1">
                     <a:tint val="75000"/>
@@ -1734,7 +1742,7 @@
               <a:tabLst>
                 <a:tab pos="0" algn="l"/>
               </a:tabLst>
-              <a:defRPr lang="en-IL" sz="1200" b="0" u="none" strike="noStrike">
+              <a:defRPr lang="x-none" sz="1200" b="0" u="none" strike="noStrike">
                 <a:solidFill>
                   <a:schemeClr val="dk1">
                     <a:tint val="75000"/>
@@ -1757,7 +1765,7 @@
               </a:tabLst>
             </a:pPr>
             <a:r>
-              <a:rPr lang="en-IL" sz="1200" b="0" u="none" strike="noStrike">
+              <a:rPr lang="x-none" sz="1200" b="0" u="none" strike="noStrike">
                 <a:solidFill>
                   <a:schemeClr val="dk1">
                     <a:tint val="75000"/>
@@ -1886,7 +1894,7 @@
               <a:tabLst>
                 <a:tab pos="0" algn="l"/>
               </a:tabLst>
-              <a:defRPr lang="en-IL" sz="1200" b="0" u="none" strike="noStrike">
+              <a:defRPr lang="x-none" sz="1200" b="0" u="none" strike="noStrike">
                 <a:solidFill>
                   <a:schemeClr val="dk1">
                     <a:tint val="75000"/>
@@ -1909,7 +1917,7 @@
               </a:tabLst>
             </a:pPr>
             <a:fld id="{DCFC6495-8D79-4CFF-B5E9-679EA4901923}" type="slidenum">
-              <a:rPr lang="en-IL" sz="1200" b="0" u="none" strike="noStrike">
+              <a:rPr lang="x-none" sz="1200" b="0" u="none" strike="noStrike">
                 <a:solidFill>
                   <a:schemeClr val="dk1">
                     <a:tint val="75000"/>
@@ -2151,7 +2159,7 @@
               <a:tabLst>
                 <a:tab pos="0" algn="l"/>
               </a:tabLst>
-              <a:defRPr lang="en-IL" sz="1200" b="0" u="none" strike="noStrike">
+              <a:defRPr lang="x-none" sz="1200" b="0" u="none" strike="noStrike">
                 <a:solidFill>
                   <a:schemeClr val="dk1">
                     <a:tint val="75000"/>
@@ -2174,7 +2182,7 @@
               </a:tabLst>
             </a:pPr>
             <a:r>
-              <a:rPr lang="en-IL" sz="1200" b="0" u="none" strike="noStrike">
+              <a:rPr lang="x-none" sz="1200" b="0" u="none" strike="noStrike">
                 <a:solidFill>
                   <a:schemeClr val="dk1">
                     <a:tint val="75000"/>
@@ -2303,7 +2311,7 @@
               <a:tabLst>
                 <a:tab pos="0" algn="l"/>
               </a:tabLst>
-              <a:defRPr lang="en-IL" sz="1200" b="0" u="none" strike="noStrike">
+              <a:defRPr lang="x-none" sz="1200" b="0" u="none" strike="noStrike">
                 <a:solidFill>
                   <a:schemeClr val="dk1">
                     <a:tint val="75000"/>
@@ -2326,7 +2334,7 @@
               </a:tabLst>
             </a:pPr>
             <a:fld id="{1A7D9BC1-D170-4732-A7B4-8079B5F63717}" type="slidenum">
-              <a:rPr lang="en-IL" sz="1200" b="0" u="none" strike="noStrike">
+              <a:rPr lang="x-none" sz="1200" b="0" u="none" strike="noStrike">
                 <a:solidFill>
                   <a:schemeClr val="dk1">
                     <a:tint val="75000"/>
@@ -3248,7 +3256,7 @@
               <a:tabLst>
                 <a:tab pos="0" algn="l"/>
               </a:tabLst>
-              <a:defRPr lang="en-IL" sz="1200" b="0" u="none" strike="noStrike">
+              <a:defRPr lang="x-none" sz="1200" b="0" u="none" strike="noStrike">
                 <a:solidFill>
                   <a:schemeClr val="dk1">
                     <a:tint val="75000"/>
@@ -3271,7 +3279,7 @@
               </a:tabLst>
             </a:pPr>
             <a:r>
-              <a:rPr lang="en-IL" sz="1200" b="0" u="none" strike="noStrike">
+              <a:rPr lang="x-none" sz="1200" b="0" u="none" strike="noStrike">
                 <a:solidFill>
                   <a:schemeClr val="dk1">
                     <a:tint val="75000"/>
@@ -3400,7 +3408,7 @@
               <a:tabLst>
                 <a:tab pos="0" algn="l"/>
               </a:tabLst>
-              <a:defRPr lang="en-IL" sz="1200" b="0" u="none" strike="noStrike">
+              <a:defRPr lang="x-none" sz="1200" b="0" u="none" strike="noStrike">
                 <a:solidFill>
                   <a:schemeClr val="dk1">
                     <a:tint val="75000"/>
@@ -3423,7 +3431,7 @@
               </a:tabLst>
             </a:pPr>
             <a:fld id="{C5B16A08-1D49-4D05-8222-C635F143A348}" type="slidenum">
-              <a:rPr lang="en-IL" sz="1200" b="0" u="none" strike="noStrike">
+              <a:rPr lang="x-none" sz="1200" b="0" u="none" strike="noStrike">
                 <a:solidFill>
                   <a:schemeClr val="dk1">
                     <a:tint val="75000"/>
@@ -3585,7 +3593,7 @@
               <a:tabLst>
                 <a:tab pos="0" algn="l"/>
               </a:tabLst>
-              <a:defRPr lang="en-IL" sz="1200" b="0" u="none" strike="noStrike">
+              <a:defRPr lang="x-none" sz="1200" b="0" u="none" strike="noStrike">
                 <a:solidFill>
                   <a:schemeClr val="dk1">
                     <a:tint val="75000"/>
@@ -3608,7 +3616,7 @@
               </a:tabLst>
             </a:pPr>
             <a:r>
-              <a:rPr lang="en-IL" sz="1200" b="0" u="none" strike="noStrike">
+              <a:rPr lang="x-none" sz="1200" b="0" u="none" strike="noStrike">
                 <a:solidFill>
                   <a:schemeClr val="dk1">
                     <a:tint val="75000"/>
@@ -3737,7 +3745,7 @@
               <a:tabLst>
                 <a:tab pos="0" algn="l"/>
               </a:tabLst>
-              <a:defRPr lang="en-IL" sz="1200" b="0" u="none" strike="noStrike">
+              <a:defRPr lang="x-none" sz="1200" b="0" u="none" strike="noStrike">
                 <a:solidFill>
                   <a:schemeClr val="dk1">
                     <a:tint val="75000"/>
@@ -3760,7 +3768,7 @@
               </a:tabLst>
             </a:pPr>
             <a:fld id="{19903630-ED88-4EE1-8544-B15362092D5A}" type="slidenum">
-              <a:rPr lang="en-IL" sz="1200" b="0" u="none" strike="noStrike">
+              <a:rPr lang="x-none" sz="1200" b="0" u="none" strike="noStrike">
                 <a:solidFill>
                   <a:schemeClr val="dk1">
                     <a:tint val="75000"/>
@@ -3852,7 +3860,7 @@
               <a:tabLst>
                 <a:tab pos="0" algn="l"/>
               </a:tabLst>
-              <a:defRPr lang="en-IL" sz="1200" b="0" u="none" strike="noStrike">
+              <a:defRPr lang="x-none" sz="1200" b="0" u="none" strike="noStrike">
                 <a:solidFill>
                   <a:schemeClr val="dk1">
                     <a:tint val="75000"/>
@@ -3875,7 +3883,7 @@
               </a:tabLst>
             </a:pPr>
             <a:r>
-              <a:rPr lang="en-IL" sz="1200" b="0" u="none" strike="noStrike">
+              <a:rPr lang="x-none" sz="1200" b="0" u="none" strike="noStrike">
                 <a:solidFill>
                   <a:schemeClr val="dk1">
                     <a:tint val="75000"/>
@@ -4004,7 +4012,7 @@
               <a:tabLst>
                 <a:tab pos="0" algn="l"/>
               </a:tabLst>
-              <a:defRPr lang="en-IL" sz="1200" b="0" u="none" strike="noStrike">
+              <a:defRPr lang="x-none" sz="1200" b="0" u="none" strike="noStrike">
                 <a:solidFill>
                   <a:schemeClr val="dk1">
                     <a:tint val="75000"/>
@@ -4027,7 +4035,7 @@
               </a:tabLst>
             </a:pPr>
             <a:fld id="{3458EDF7-AE9E-4A28-94A9-890CC40594A2}" type="slidenum">
-              <a:rPr lang="en-IL" sz="1200" b="0" u="none" strike="noStrike">
+              <a:rPr lang="x-none" sz="1200" b="0" u="none" strike="noStrike">
                 <a:solidFill>
                   <a:schemeClr val="dk1">
                     <a:tint val="75000"/>
@@ -4086,7 +4094,7 @@
               <a:tabLst>
                 <a:tab pos="0" algn="l"/>
               </a:tabLst>
-              <a:defRPr lang="en-IL" sz="4400" b="0" u="none" strike="noStrike">
+              <a:defRPr lang="x-none" sz="4400" b="0" u="none" strike="noStrike">
                 <a:solidFill>
                   <a:schemeClr val="dk1"/>
                 </a:solidFill>
@@ -4107,7 +4115,7 @@
               </a:tabLst>
             </a:pPr>
             <a:r>
-              <a:rPr lang="en-IL" sz="4400" b="0" u="none" strike="noStrike">
+              <a:rPr lang="x-none" sz="4400" b="0" u="none" strike="noStrike">
                 <a:solidFill>
                   <a:schemeClr val="dk1"/>
                 </a:solidFill>
@@ -4160,7 +4168,7 @@
               </a:buClr>
               <a:buFont typeface="Arial"/>
               <a:buChar char="•"/>
-              <a:defRPr lang="en-IL" sz="2800" b="0" u="none" strike="noStrike">
+              <a:defRPr lang="x-none" sz="2800" b="0" u="none" strike="noStrike">
                 <a:solidFill>
                   <a:schemeClr val="dk1"/>
                 </a:solidFill>
@@ -4182,7 +4190,7 @@
               <a:buSzPct val="75000"/>
               <a:buFont typeface="Symbol" charset="2"/>
               <a:buChar char=""/>
-              <a:defRPr lang="en-IL" sz="2400" b="0" u="none" strike="noStrike">
+              <a:defRPr lang="x-none" sz="2400" b="0" u="none" strike="noStrike">
                 <a:solidFill>
                   <a:schemeClr val="dk1"/>
                 </a:solidFill>
@@ -4204,7 +4212,7 @@
               <a:buSzPct val="45000"/>
               <a:buFont typeface="Wingdings" charset="2"/>
               <a:buChar char=""/>
-              <a:defRPr lang="en-IL" sz="2000" b="0" u="none" strike="noStrike">
+              <a:defRPr lang="x-none" sz="2000" b="0" u="none" strike="noStrike">
                 <a:solidFill>
                   <a:schemeClr val="dk1"/>
                 </a:solidFill>
@@ -4226,7 +4234,7 @@
               <a:buSzPct val="75000"/>
               <a:buFont typeface="Symbol" charset="2"/>
               <a:buChar char=""/>
-              <a:defRPr lang="en-IL" sz="1800" b="0" u="none" strike="noStrike">
+              <a:defRPr lang="x-none" sz="1800" b="0" u="none" strike="noStrike">
                 <a:solidFill>
                   <a:schemeClr val="dk1"/>
                 </a:solidFill>
@@ -4248,7 +4256,7 @@
               <a:buSzPct val="45000"/>
               <a:buFont typeface="Wingdings" charset="2"/>
               <a:buChar char=""/>
-              <a:defRPr lang="en-IL" sz="1800" b="0" u="none" strike="noStrike">
+              <a:defRPr lang="x-none" sz="1800" b="0" u="none" strike="noStrike">
                 <a:solidFill>
                   <a:schemeClr val="dk1"/>
                 </a:solidFill>
@@ -4270,7 +4278,7 @@
               <a:buSzPct val="45000"/>
               <a:buFont typeface="Wingdings" charset="2"/>
               <a:buChar char=""/>
-              <a:defRPr lang="en-IL" sz="2000" b="0" u="none" strike="noStrike">
+              <a:defRPr lang="x-none" sz="2000" b="0" u="none" strike="noStrike">
                 <a:solidFill>
                   <a:schemeClr val="dk1"/>
                 </a:solidFill>
@@ -4292,7 +4300,7 @@
               <a:buSzPct val="45000"/>
               <a:buFont typeface="Wingdings" charset="2"/>
               <a:buChar char=""/>
-              <a:defRPr lang="en-IL" sz="2000" b="0" u="none" strike="noStrike">
+              <a:defRPr lang="x-none" sz="2000" b="0" u="none" strike="noStrike">
                 <a:solidFill>
                   <a:schemeClr val="dk1"/>
                 </a:solidFill>
@@ -4317,7 +4325,7 @@
               <a:buChar char="•"/>
             </a:pPr>
             <a:r>
-              <a:rPr lang="en-IL" sz="2800" b="0" u="none" strike="noStrike">
+              <a:rPr lang="x-none" sz="2800" b="0" u="none" strike="noStrike">
                 <a:solidFill>
                   <a:schemeClr val="dk1"/>
                 </a:solidFill>
@@ -4344,7 +4352,7 @@
               <a:buChar char=""/>
             </a:pPr>
             <a:r>
-              <a:rPr lang="en-IL" sz="2400" b="0" u="none" strike="noStrike">
+              <a:rPr lang="x-none" sz="2400" b="0" u="none" strike="noStrike">
                 <a:solidFill>
                   <a:schemeClr val="dk1"/>
                 </a:solidFill>
@@ -4371,7 +4379,7 @@
               <a:buChar char=""/>
             </a:pPr>
             <a:r>
-              <a:rPr lang="en-IL" sz="2000" b="0" u="none" strike="noStrike">
+              <a:rPr lang="x-none" sz="2000" b="0" u="none" strike="noStrike">
                 <a:solidFill>
                   <a:schemeClr val="dk1"/>
                 </a:solidFill>
@@ -4398,7 +4406,7 @@
               <a:buChar char=""/>
             </a:pPr>
             <a:r>
-              <a:rPr lang="en-IL" sz="1800" b="0" u="none" strike="noStrike">
+              <a:rPr lang="x-none" sz="1800" b="0" u="none" strike="noStrike">
                 <a:solidFill>
                   <a:schemeClr val="dk1"/>
                 </a:solidFill>
@@ -4425,7 +4433,7 @@
               <a:buChar char=""/>
             </a:pPr>
             <a:r>
-              <a:rPr lang="en-IL" sz="1800" b="0" u="none" strike="noStrike">
+              <a:rPr lang="x-none" sz="1800" b="0" u="none" strike="noStrike">
                 <a:solidFill>
                   <a:schemeClr val="dk1"/>
                 </a:solidFill>
@@ -4452,7 +4460,7 @@
               <a:buChar char=""/>
             </a:pPr>
             <a:r>
-              <a:rPr lang="en-IL" sz="2000" b="0" u="none" strike="noStrike">
+              <a:rPr lang="x-none" sz="2000" b="0" u="none" strike="noStrike">
                 <a:solidFill>
                   <a:schemeClr val="dk1"/>
                 </a:solidFill>
@@ -4479,7 +4487,7 @@
               <a:buChar char=""/>
             </a:pPr>
             <a:r>
-              <a:rPr lang="en-IL" sz="2000" b="0" u="none" strike="noStrike">
+              <a:rPr lang="x-none" sz="2000" b="0" u="none" strike="noStrike">
                 <a:solidFill>
                   <a:schemeClr val="dk1"/>
                 </a:solidFill>
@@ -4973,7 +4981,7 @@
               <a:tabLst>
                 <a:tab pos="0" algn="l"/>
               </a:tabLst>
-              <a:defRPr lang="en-IL" sz="1200" b="0" u="none" strike="noStrike">
+              <a:defRPr lang="x-none" sz="1200" b="0" u="none" strike="noStrike">
                 <a:solidFill>
                   <a:schemeClr val="dk1">
                     <a:tint val="75000"/>
@@ -4996,7 +5004,7 @@
               </a:tabLst>
             </a:pPr>
             <a:r>
-              <a:rPr lang="en-IL" sz="1200" b="0" u="none" strike="noStrike">
+              <a:rPr lang="x-none" sz="1200" b="0" u="none" strike="noStrike">
                 <a:solidFill>
                   <a:schemeClr val="dk1">
                     <a:tint val="75000"/>
@@ -5125,7 +5133,7 @@
               <a:tabLst>
                 <a:tab pos="0" algn="l"/>
               </a:tabLst>
-              <a:defRPr lang="en-IL" sz="1200" b="0" u="none" strike="noStrike">
+              <a:defRPr lang="x-none" sz="1200" b="0" u="none" strike="noStrike">
                 <a:solidFill>
                   <a:schemeClr val="dk1">
                     <a:tint val="75000"/>
@@ -5148,7 +5156,7 @@
               </a:tabLst>
             </a:pPr>
             <a:fld id="{BBA1531D-7388-46B1-B8B8-68A23A8BC79A}" type="slidenum">
-              <a:rPr lang="en-IL" sz="1200" b="0" u="none" strike="noStrike">
+              <a:rPr lang="x-none" sz="1200" b="0" u="none" strike="noStrike">
                 <a:solidFill>
                   <a:schemeClr val="dk1">
                     <a:tint val="75000"/>
@@ -5432,7 +5440,7 @@
               <a:tabLst>
                 <a:tab pos="0" algn="l"/>
               </a:tabLst>
-              <a:defRPr lang="en-IL" sz="1200" b="0" u="none" strike="noStrike">
+              <a:defRPr lang="x-none" sz="1200" b="0" u="none" strike="noStrike">
                 <a:solidFill>
                   <a:schemeClr val="dk1">
                     <a:tint val="75000"/>
@@ -5455,7 +5463,7 @@
               </a:tabLst>
             </a:pPr>
             <a:r>
-              <a:rPr lang="en-IL" sz="1200" b="0" u="none" strike="noStrike">
+              <a:rPr lang="x-none" sz="1200" b="0" u="none" strike="noStrike">
                 <a:solidFill>
                   <a:schemeClr val="dk1">
                     <a:tint val="75000"/>
@@ -5584,7 +5592,7 @@
               <a:tabLst>
                 <a:tab pos="0" algn="l"/>
               </a:tabLst>
-              <a:defRPr lang="en-IL" sz="1200" b="0" u="none" strike="noStrike">
+              <a:defRPr lang="x-none" sz="1200" b="0" u="none" strike="noStrike">
                 <a:solidFill>
                   <a:schemeClr val="dk1">
                     <a:tint val="75000"/>
@@ -5607,7 +5615,7 @@
               </a:tabLst>
             </a:pPr>
             <a:fld id="{76922409-5C0F-4E6F-BB09-DE198C25E6BD}" type="slidenum">
-              <a:rPr lang="en-IL" sz="1200" b="0" u="none" strike="noStrike">
+              <a:rPr lang="x-none" sz="1200" b="0" u="none" strike="noStrike">
                 <a:solidFill>
                   <a:schemeClr val="dk1">
                     <a:tint val="75000"/>
@@ -5769,7 +5777,7 @@
               <a:tabLst>
                 <a:tab pos="0" algn="l"/>
               </a:tabLst>
-              <a:defRPr lang="en-IL" sz="1200" b="0" u="none" strike="noStrike">
+              <a:defRPr lang="x-none" sz="1200" b="0" u="none" strike="noStrike">
                 <a:solidFill>
                   <a:schemeClr val="dk1">
                     <a:tint val="75000"/>
@@ -5792,7 +5800,7 @@
               </a:tabLst>
             </a:pPr>
             <a:r>
-              <a:rPr lang="en-IL" sz="1200" b="0" u="none" strike="noStrike">
+              <a:rPr lang="x-none" sz="1200" b="0" u="none" strike="noStrike">
                 <a:solidFill>
                   <a:schemeClr val="dk1">
                     <a:tint val="75000"/>
@@ -5921,7 +5929,7 @@
               <a:tabLst>
                 <a:tab pos="0" algn="l"/>
               </a:tabLst>
-              <a:defRPr lang="en-IL" sz="1200" b="0" u="none" strike="noStrike">
+              <a:defRPr lang="x-none" sz="1200" b="0" u="none" strike="noStrike">
                 <a:solidFill>
                   <a:schemeClr val="dk1">
                     <a:tint val="75000"/>
@@ -5944,7 +5952,7 @@
               </a:tabLst>
             </a:pPr>
             <a:fld id="{1A8C7008-9342-4EA7-B80A-31098A996368}" type="slidenum">
-              <a:rPr lang="en-IL" sz="1200" b="0" u="none" strike="noStrike">
+              <a:rPr lang="x-none" sz="1200" b="0" u="none" strike="noStrike">
                 <a:solidFill>
                   <a:schemeClr val="dk1">
                     <a:tint val="75000"/>
@@ -6007,7 +6015,7 @@
               </a:buClr>
               <a:buFont typeface="Arial"/>
               <a:buChar char="•"/>
-              <a:defRPr lang="en-IL" sz="2800" b="0" u="none" strike="noStrike">
+              <a:defRPr lang="x-none" sz="2800" b="0" u="none" strike="noStrike">
                 <a:solidFill>
                   <a:schemeClr val="dk1"/>
                 </a:solidFill>
@@ -6029,7 +6037,7 @@
               <a:buSzPct val="75000"/>
               <a:buFont typeface="Symbol" charset="2"/>
               <a:buChar char=""/>
-              <a:defRPr lang="en-IL" sz="2400" b="0" u="none" strike="noStrike">
+              <a:defRPr lang="x-none" sz="2400" b="0" u="none" strike="noStrike">
                 <a:solidFill>
                   <a:schemeClr val="dk1"/>
                 </a:solidFill>
@@ -6051,7 +6059,7 @@
               <a:buSzPct val="45000"/>
               <a:buFont typeface="Wingdings" charset="2"/>
               <a:buChar char=""/>
-              <a:defRPr lang="en-IL" sz="2000" b="0" u="none" strike="noStrike">
+              <a:defRPr lang="x-none" sz="2000" b="0" u="none" strike="noStrike">
                 <a:solidFill>
                   <a:schemeClr val="dk1"/>
                 </a:solidFill>
@@ -6073,7 +6081,7 @@
               <a:buSzPct val="75000"/>
               <a:buFont typeface="Symbol" charset="2"/>
               <a:buChar char=""/>
-              <a:defRPr lang="en-IL" sz="1800" b="0" u="none" strike="noStrike">
+              <a:defRPr lang="x-none" sz="1800" b="0" u="none" strike="noStrike">
                 <a:solidFill>
                   <a:schemeClr val="dk1"/>
                 </a:solidFill>
@@ -6095,7 +6103,7 @@
               <a:buSzPct val="45000"/>
               <a:buFont typeface="Wingdings" charset="2"/>
               <a:buChar char=""/>
-              <a:defRPr lang="en-IL" sz="1800" b="0" u="none" strike="noStrike">
+              <a:defRPr lang="x-none" sz="1800" b="0" u="none" strike="noStrike">
                 <a:solidFill>
                   <a:schemeClr val="dk1"/>
                 </a:solidFill>
@@ -6117,7 +6125,7 @@
               <a:buSzPct val="45000"/>
               <a:buFont typeface="Wingdings" charset="2"/>
               <a:buChar char=""/>
-              <a:defRPr lang="en-IL" sz="2000" b="0" u="none" strike="noStrike">
+              <a:defRPr lang="x-none" sz="2000" b="0" u="none" strike="noStrike">
                 <a:solidFill>
                   <a:schemeClr val="dk1"/>
                 </a:solidFill>
@@ -6139,7 +6147,7 @@
               <a:buSzPct val="45000"/>
               <a:buFont typeface="Wingdings" charset="2"/>
               <a:buChar char=""/>
-              <a:defRPr lang="en-IL" sz="2000" b="0" u="none" strike="noStrike">
+              <a:defRPr lang="x-none" sz="2000" b="0" u="none" strike="noStrike">
                 <a:solidFill>
                   <a:schemeClr val="dk1"/>
                 </a:solidFill>
@@ -6164,7 +6172,7 @@
               <a:buChar char="•"/>
             </a:pPr>
             <a:r>
-              <a:rPr lang="en-IL" sz="2800" b="0" u="none" strike="noStrike">
+              <a:rPr lang="x-none" sz="2800" b="0" u="none" strike="noStrike">
                 <a:solidFill>
                   <a:schemeClr val="dk1"/>
                 </a:solidFill>
@@ -6191,7 +6199,7 @@
               <a:buChar char=""/>
             </a:pPr>
             <a:r>
-              <a:rPr lang="en-IL" sz="2400" b="0" u="none" strike="noStrike">
+              <a:rPr lang="x-none" sz="2400" b="0" u="none" strike="noStrike">
                 <a:solidFill>
                   <a:schemeClr val="dk1"/>
                 </a:solidFill>
@@ -6218,7 +6226,7 @@
               <a:buChar char=""/>
             </a:pPr>
             <a:r>
-              <a:rPr lang="en-IL" sz="2000" b="0" u="none" strike="noStrike">
+              <a:rPr lang="x-none" sz="2000" b="0" u="none" strike="noStrike">
                 <a:solidFill>
                   <a:schemeClr val="dk1"/>
                 </a:solidFill>
@@ -6245,7 +6253,7 @@
               <a:buChar char=""/>
             </a:pPr>
             <a:r>
-              <a:rPr lang="en-IL" sz="1800" b="0" u="none" strike="noStrike">
+              <a:rPr lang="x-none" sz="1800" b="0" u="none" strike="noStrike">
                 <a:solidFill>
                   <a:schemeClr val="dk1"/>
                 </a:solidFill>
@@ -6272,7 +6280,7 @@
               <a:buChar char=""/>
             </a:pPr>
             <a:r>
-              <a:rPr lang="en-IL" sz="1800" b="0" u="none" strike="noStrike">
+              <a:rPr lang="x-none" sz="1800" b="0" u="none" strike="noStrike">
                 <a:solidFill>
                   <a:schemeClr val="dk1"/>
                 </a:solidFill>
@@ -6299,7 +6307,7 @@
               <a:buChar char=""/>
             </a:pPr>
             <a:r>
-              <a:rPr lang="en-IL" sz="2000" b="0" u="none" strike="noStrike">
+              <a:rPr lang="x-none" sz="2000" b="0" u="none" strike="noStrike">
                 <a:solidFill>
                   <a:schemeClr val="dk1"/>
                 </a:solidFill>
@@ -6326,7 +6334,7 @@
               <a:buChar char=""/>
             </a:pPr>
             <a:r>
-              <a:rPr lang="en-IL" sz="2000" b="0" u="none" strike="noStrike">
+              <a:rPr lang="x-none" sz="2000" b="0" u="none" strike="noStrike">
                 <a:solidFill>
                   <a:schemeClr val="dk1"/>
                 </a:solidFill>
@@ -6744,7 +6752,7 @@
               <a:tabLst>
                 <a:tab pos="0" algn="l"/>
               </a:tabLst>
-              <a:defRPr lang="en-IL" sz="1200" b="0" u="none" strike="noStrike">
+              <a:defRPr lang="x-none" sz="1200" b="0" u="none" strike="noStrike">
                 <a:solidFill>
                   <a:schemeClr val="dk1">
                     <a:tint val="75000"/>
@@ -6767,7 +6775,7 @@
               </a:tabLst>
             </a:pPr>
             <a:r>
-              <a:rPr lang="en-IL" sz="1200" b="0" u="none" strike="noStrike">
+              <a:rPr lang="x-none" sz="1200" b="0" u="none" strike="noStrike">
                 <a:solidFill>
                   <a:schemeClr val="dk1">
                     <a:tint val="75000"/>
@@ -6896,7 +6904,7 @@
               <a:tabLst>
                 <a:tab pos="0" algn="l"/>
               </a:tabLst>
-              <a:defRPr lang="en-IL" sz="1200" b="0" u="none" strike="noStrike">
+              <a:defRPr lang="x-none" sz="1200" b="0" u="none" strike="noStrike">
                 <a:solidFill>
                   <a:schemeClr val="dk1">
                     <a:tint val="75000"/>
@@ -6919,7 +6927,7 @@
               </a:tabLst>
             </a:pPr>
             <a:fld id="{10C1B76E-2C69-4E12-8968-8BD01CE3FB9D}" type="slidenum">
-              <a:rPr lang="en-IL" sz="1200" b="0" u="none" strike="noStrike">
+              <a:rPr lang="x-none" sz="1200" b="0" u="none" strike="noStrike">
                 <a:solidFill>
                   <a:schemeClr val="dk1">
                     <a:tint val="75000"/>
@@ -7347,7 +7355,7 @@
               <a:tabLst>
                 <a:tab pos="0" algn="l"/>
               </a:tabLst>
-              <a:defRPr lang="en-IL" sz="1200" b="0" u="none" strike="noStrike">
+              <a:defRPr lang="x-none" sz="1200" b="0" u="none" strike="noStrike">
                 <a:solidFill>
                   <a:schemeClr val="dk1">
                     <a:tint val="75000"/>
@@ -7370,7 +7378,7 @@
               </a:tabLst>
             </a:pPr>
             <a:r>
-              <a:rPr lang="en-IL" sz="1200" b="0" u="none" strike="noStrike">
+              <a:rPr lang="x-none" sz="1200" b="0" u="none" strike="noStrike">
                 <a:solidFill>
                   <a:schemeClr val="dk1">
                     <a:tint val="75000"/>
@@ -7499,7 +7507,7 @@
               <a:tabLst>
                 <a:tab pos="0" algn="l"/>
               </a:tabLst>
-              <a:defRPr lang="en-IL" sz="1200" b="0" u="none" strike="noStrike">
+              <a:defRPr lang="x-none" sz="1200" b="0" u="none" strike="noStrike">
                 <a:solidFill>
                   <a:schemeClr val="dk1">
                     <a:tint val="75000"/>
@@ -7522,7 +7530,7 @@
               </a:tabLst>
             </a:pPr>
             <a:fld id="{6DD535B1-ACF6-4587-9162-5B5394E6C0A2}" type="slidenum">
-              <a:rPr lang="en-IL" sz="1200" b="0" u="none" strike="noStrike">
+              <a:rPr lang="x-none" sz="1200" b="0" u="none" strike="noStrike">
                 <a:solidFill>
                   <a:schemeClr val="dk1">
                     <a:tint val="75000"/>
@@ -7777,7 +7785,7 @@
     </p:bodyStyle>
     <p:otherStyle>
       <a:defPPr>
-        <a:defRPr lang="LID4096"/>
+        <a:defRPr lang="x-none"/>
       </a:defPPr>
       <a:lvl1pPr marL="0" algn="l" defTabSz="914400" rtl="0" eaLnBrk="1" latinLnBrk="0" hangingPunct="1">
         <a:defRPr sz="1800" kern="1200">
@@ -7914,7 +7922,7 @@
           <a:noFill/>
         </p:spPr>
         <p:txBody>
-          <a:bodyPr wrap="square" rtlCol="0">
+          <a:bodyPr wrap="square" lIns="91440" tIns="45720" rIns="91440" bIns="45720" rtlCol="0" anchor="t">
             <a:spAutoFit/>
           </a:bodyPr>
           <a:lstStyle/>
@@ -7927,8 +7935,63 @@
           <a:p>
             <a:r>
               <a:rPr lang="en-US" dirty="0"/>
-              <a:t>"clock_tick_seconds": 1.0,</a:t>
-            </a:r>
+              <a:t>"</a:t>
+            </a:r>
+            <a:r>
+              <a:rPr lang="en-US" dirty="0" err="1"/>
+              <a:t>clock_tick_seconds</a:t>
+            </a:r>
+            <a:r>
+              <a:rPr lang="en-US" dirty="0"/>
+              <a:t>": 1.0,</a:t>
+            </a:r>
+          </a:p>
+          <a:p>
+            <a:r>
+              <a:rPr lang="en-US" dirty="0"/>
+              <a:t>"mock_start_datetime": </a:t>
+            </a:r>
+            <a:r>
+              <a:rPr lang="en-US"/>
+              <a:t>“2026-10-10T23:47:30</a:t>
+            </a:r>
+            <a:r>
+              <a:rPr lang="en-US" dirty="0"/>
+              <a:t>”,</a:t>
+            </a:r>
+            <a:endParaRPr lang="en-US" dirty="0">
+              <a:ea typeface="Calibri"/>
+              <a:cs typeface="Calibri"/>
+            </a:endParaRPr>
+          </a:p>
+          <a:p>
+            <a:r>
+              <a:rPr lang="en-US" dirty="0"/>
+              <a:t>“_</a:t>
+            </a:r>
+            <a:r>
+              <a:rPr lang="en-US" dirty="0" err="1"/>
+              <a:t>debug_repaint_lock_controllers</a:t>
+            </a:r>
+            <a:r>
+              <a:rPr lang="en-US" dirty="0"/>
+              <a:t>": false,</a:t>
+            </a:r>
+          </a:p>
+          <a:p>
+            <a:r>
+              <a:rPr lang="" dirty="0"/>
+              <a:t>“_</a:t>
+            </a:r>
+            <a:r>
+              <a:rPr lang="" dirty="0" err="1"/>
+              <a:t>debug_skip_slideshow</a:t>
+            </a:r>
+            <a:r>
+              <a:rPr lang="" dirty="0"/>
+              <a:t>": true,</a:t>
+            </a:r>
+            <a:endParaRPr lang="en-US" dirty="0"/>
           </a:p>
           <a:p>
             <a:r>
@@ -7936,45 +7999,6 @@
               <a:t>"</a:t>
             </a:r>
             <a:r>
-              <a:rPr lang="he-IL" dirty="0"/>
-              <a:t>_</a:t>
-            </a:r>
-            <a:r>
-              <a:rPr lang="en-US" dirty="0" err="1"/>
-              <a:t>mock_start_datetime</a:t>
-            </a:r>
-            <a:r>
-              <a:rPr lang="en-US" dirty="0"/>
-              <a:t>": "2026-03-28T14:30:00",</a:t>
-            </a:r>
-          </a:p>
-          <a:p>
-            <a:r>
-              <a:rPr lang="en-US" dirty="0"/>
-              <a:t>“_</a:t>
-            </a:r>
-            <a:r>
-              <a:rPr lang="en-US" dirty="0" err="1"/>
-              <a:t>debug_repaint_lock_controllers</a:t>
-            </a:r>
-            <a:r>
-              <a:rPr lang="en-US" dirty="0"/>
-              <a:t>": false,</a:t>
-            </a:r>
-          </a:p>
-          <a:p>
-            <a:r>
-              <a:rPr lang="" dirty="0"/>
-              <a:t>“_debug_skip_slideshow": true,</a:t>
-            </a:r>
-            <a:endParaRPr lang="en-US" dirty="0"/>
-          </a:p>
-          <a:p>
-            <a:r>
-              <a:rPr lang="en-US" dirty="0"/>
-              <a:t>"</a:t>
-            </a:r>
-            <a:r>
               <a:rPr lang="en-US" dirty="0" err="1"/>
               <a:t>clock_style</a:t>
             </a:r>
@@ -7984,7 +8008,15 @@
             </a:r>
             <a:r>
               <a:rPr lang="" dirty="0"/>
-              <a:t>"hour_color": 0</a:t>
+              <a:t>"</a:t>
+            </a:r>
+            <a:r>
+              <a:rPr lang="" dirty="0" err="1"/>
+              <a:t>hour_color</a:t>
+            </a:r>
+            <a:r>
+              <a:rPr lang="" dirty="0"/>
+              <a:t>": 0</a:t>
             </a:r>
             <a:r>
               <a:rPr lang="en-US" dirty="0"/>
@@ -7996,7 +8028,7 @@
               <a:rPr lang="en-US" dirty="0"/>
               <a:t>}</a:t>
             </a:r>
-            <a:endParaRPr lang="LID4096" dirty="0"/>
+            <a:endParaRPr lang="x-none" dirty="0"/>
           </a:p>
         </p:txBody>
       </p:sp>
@@ -9601,13 +9633,13 @@
   <p:clrMapOvr>
     <a:masterClrMapping/>
   </p:clrMapOvr>
-  <mc:AlternateContent xmlns:mc="http://schemas.openxmlformats.org/markup-compatibility/2006">
-    <mc:Choice xmlns:p14="http://schemas.microsoft.com/office/powerpoint/2010/main" Requires="p14">
+  <mc:AlternateContent xmlns:mc="http://schemas.openxmlformats.org/markup-compatibility/2006" xmlns:p14="http://schemas.microsoft.com/office/powerpoint/2010/main">
+    <mc:Choice Requires="p14">
       <p:transition spd="med" p14:dur="700" advTm="40000">
         <p:fade/>
       </p:transition>
     </mc:Choice>
-    <mc:Fallback>
+    <mc:Fallback xmlns="">
       <p:transition spd="med" advTm="40000">
         <p:fade/>
       </p:transition>
@@ -9772,7 +9804,7 @@
           <a:fontRef idx="minor"/>
         </p:style>
         <p:txBody>
-          <a:bodyPr wrap="square" lIns="90000" tIns="45000" rIns="90000" bIns="45000" anchor="ctr" anchorCtr="0">
+          <a:bodyPr wrap="none" lIns="90000" tIns="45000" rIns="90000" bIns="45000" anchor="ctr" anchorCtr="0">
             <a:normAutofit/>
           </a:bodyPr>
           <a:lstStyle/>
@@ -11134,7 +11166,7 @@
               </a:rPr>
               <a:t>בברכת שבת שלום!</a:t>
             </a:r>
-            <a:endParaRPr lang="LID4096" sz="8800" b="1" dirty="0">
+            <a:endParaRPr lang="x-none" sz="8800" b="1" dirty="0">
               <a:ln w="6600">
                 <a:solidFill>
                   <a:schemeClr val="accent2"/>
@@ -11308,7 +11340,7 @@
               </a:rPr>
               <a:t>#DICLOCK</a:t>
             </a:r>
-            <a:endParaRPr lang="LID4096" sz="4000" dirty="0">
+            <a:endParaRPr lang="x-none" sz="4000" dirty="0">
               <a:ln w="12700" cmpd="sng">
                 <a:solidFill>
                   <a:schemeClr val="accent4"/>
@@ -11349,13 +11381,13 @@
   <p:clrMapOvr>
     <a:masterClrMapping/>
   </p:clrMapOvr>
-  <mc:AlternateContent xmlns:mc="http://schemas.openxmlformats.org/markup-compatibility/2006" xmlns:p14="http://schemas.microsoft.com/office/powerpoint/2010/main">
-    <mc:Choice Requires="p14">
+  <mc:AlternateContent xmlns:mc="http://schemas.openxmlformats.org/markup-compatibility/2006">
+    <mc:Choice xmlns:p14="http://schemas.microsoft.com/office/powerpoint/2010/main" Requires="p14">
       <p:transition spd="med" p14:dur="700" advTm="10000">
         <p:fade/>
       </p:transition>
     </mc:Choice>
-    <mc:Fallback xmlns="">
+    <mc:Fallback>
       <p:transition spd="med" advTm="10000">
         <p:fade/>
       </p:transition>

</xml_diff>

<commit_message>
tagging: add #MOLAD tag for upcoming chodesh molad announcement
Adds a #MOLAD tag to TAG_REGISTRY, reusing pyzmanim's existing get_molad/molad_format. Always shows the molad for the NEXT Hebrew month (upcoming Rosh Chodesh) - not the current month's, since that's what's relevant for a live signage display.

4 new tests in test_tagging.py (176/176 passing).
</commit_message>
<xml_diff>
--- a/luah.pptx
+++ b/luah.pptx
@@ -7949,15 +7949,11 @@
           <a:p>
             <a:r>
               <a:rPr lang="en-US" dirty="0"/>
-              <a:t>"mock_start_datetime": </a:t>
+              <a:t>"mock_start_datetime</a:t>
             </a:r>
             <a:r>
               <a:rPr lang="en-US"/>
-              <a:t>“2026-10-10T23:47:30</a:t>
-            </a:r>
-            <a:r>
-              <a:rPr lang="en-US" dirty="0"/>
-              <a:t>”,</a:t>
+              <a:t>": null,</a:t>
             </a:r>
             <a:endParaRPr lang="en-US" dirty="0">
               <a:ea typeface="Calibri"/>
@@ -10513,39 +10509,37 @@
               </a:tabLst>
             </a:pPr>
             <a:r>
-              <a:rPr lang="he-IL" sz="2000" dirty="0">
+              <a:rPr lang="he-IL" sz="2000" b="1" u="none" strike="noStrike" dirty="0">
                 <a:solidFill>
                   <a:srgbClr val="FAF4E3"/>
                 </a:solidFill>
+                <a:effectLst/>
+                <a:uFillTx/>
                 <a:latin typeface="Arial"/>
               </a:rPr>
-              <a:t>קהילת מעשה ניסים </a:t>
+              <a:t>שבת מברכים</a:t>
             </a:r>
             <a:br>
-              <a:rPr lang="en-US" sz="2000" dirty="0">
+              <a:rPr lang="en-US" sz="2000" u="none" strike="noStrike" dirty="0">
                 <a:solidFill>
                   <a:srgbClr val="FAF4E3"/>
                 </a:solidFill>
+                <a:effectLst/>
+                <a:uFillTx/>
                 <a:latin typeface="Arial"/>
               </a:rPr>
             </a:br>
             <a:r>
-              <a:rPr lang="he-IL" sz="2000" dirty="0">
+              <a:rPr lang="en-US" sz="2000" u="none" strike="noStrike" dirty="0">
                 <a:solidFill>
                   <a:srgbClr val="FAF4E3"/>
                 </a:solidFill>
+                <a:effectLst/>
+                <a:uFillTx/>
                 <a:latin typeface="Arial"/>
               </a:rPr>
-              <a:t>מברכים את כל אורחינו בברכת שבת שלום!</a:t>
-            </a:r>
-            <a:endParaRPr lang="en-US" sz="2000" u="none" strike="noStrike" dirty="0">
-              <a:solidFill>
-                <a:srgbClr val="FAF4E3"/>
-              </a:solidFill>
-              <a:effectLst/>
-              <a:uFillTx/>
-              <a:latin typeface="Arial"/>
-            </a:endParaRPr>
+              <a:t>#MOLAD</a:t>
+            </a:r>
           </a:p>
         </p:txBody>
       </p:sp>

</xml_diff>